<commit_message>
Added link for course feedback
</commit_message>
<xml_diff>
--- a/instructors/Introduction to Web Scraping.pptx
+++ b/instructors/Introduction to Web Scraping.pptx
@@ -14,7 +14,8 @@
     <p:sldId id="263" r:id="rId8"/>
     <p:sldId id="264" r:id="rId9"/>
     <p:sldId id="265" r:id="rId10"/>
-    <p:sldId id="257" r:id="rId11"/>
+    <p:sldId id="266" r:id="rId11"/>
+    <p:sldId id="257" r:id="rId12"/>
   </p:sldIdLst>
   <p:sldSz cx="12192000" cy="6858000"/>
   <p:notesSz cx="6858000" cy="9144000"/>
@@ -9184,6 +9185,247 @@
 </p:sld>
 </file>
 
+<file path=ppt/slides/slide10.xml><?xml version="1.0" encoding="utf-8"?>
+<p:sld xmlns:a="http://schemas.openxmlformats.org/drawingml/2006/main" xmlns:r="http://schemas.openxmlformats.org/officeDocument/2006/relationships" xmlns:p="http://schemas.openxmlformats.org/presentationml/2006/main">
+  <p:cSld>
+    <p:spTree>
+      <p:nvGrpSpPr>
+        <p:cNvPr id="1" name=""/>
+        <p:cNvGrpSpPr/>
+        <p:nvPr/>
+      </p:nvGrpSpPr>
+      <p:grpSpPr>
+        <a:xfrm>
+          <a:off x="0" y="0"/>
+          <a:ext cx="0" cy="0"/>
+          <a:chOff x="0" y="0"/>
+          <a:chExt cx="0" cy="0"/>
+        </a:xfrm>
+      </p:grpSpPr>
+      <p:sp>
+        <p:nvSpPr>
+          <p:cNvPr id="2" name="Title 1">
+            <a:extLst>
+              <a:ext uri="{FF2B5EF4-FFF2-40B4-BE49-F238E27FC236}">
+                <a16:creationId xmlns:a16="http://schemas.microsoft.com/office/drawing/2014/main" id="{F7357C48-2C50-5587-5B64-24F7CE236783}"/>
+              </a:ext>
+            </a:extLst>
+          </p:cNvPr>
+          <p:cNvSpPr>
+            <a:spLocks noGrp="1"/>
+          </p:cNvSpPr>
+          <p:nvPr>
+            <p:ph type="title"/>
+          </p:nvPr>
+        </p:nvSpPr>
+        <p:spPr/>
+        <p:txBody>
+          <a:bodyPr/>
+          <a:lstStyle/>
+          <a:p>
+            <a:r>
+              <a:rPr lang="en-GB" dirty="0"/>
+              <a:t>2026 IT Needs of Active Research Survey</a:t>
+            </a:r>
+          </a:p>
+        </p:txBody>
+      </p:sp>
+      <p:sp>
+        <p:nvSpPr>
+          <p:cNvPr id="3" name="Content Placeholder 2">
+            <a:extLst>
+              <a:ext uri="{FF2B5EF4-FFF2-40B4-BE49-F238E27FC236}">
+                <a16:creationId xmlns:a16="http://schemas.microsoft.com/office/drawing/2014/main" id="{AE939116-DBB8-4101-FC45-CEDC7FD29B29}"/>
+              </a:ext>
+            </a:extLst>
+          </p:cNvPr>
+          <p:cNvSpPr>
+            <a:spLocks noGrp="1"/>
+          </p:cNvSpPr>
+          <p:nvPr>
+            <p:ph sz="half" idx="1"/>
+          </p:nvPr>
+        </p:nvSpPr>
+        <p:spPr>
+          <a:xfrm>
+            <a:off x="502921" y="1310641"/>
+            <a:ext cx="7175693" cy="4378960"/>
+          </a:xfrm>
+        </p:spPr>
+        <p:txBody>
+          <a:bodyPr>
+            <a:normAutofit/>
+          </a:bodyPr>
+          <a:lstStyle/>
+          <a:p>
+            <a:pPr marL="342900" indent="-342900">
+              <a:buFont typeface="Arial" panose="020B0604020202020204" pitchFamily="34" charset="0"/>
+              <a:buChar char="•"/>
+            </a:pPr>
+            <a:r>
+              <a:rPr lang="en-GB" sz="2200" dirty="0"/>
+              <a:t>Survey going live Monday 23 February for 4 weeks </a:t>
+            </a:r>
+          </a:p>
+          <a:p>
+            <a:pPr marL="800100" lvl="1" indent="-342900">
+              <a:buFont typeface="Arial" panose="020B0604020202020204" pitchFamily="34" charset="0"/>
+              <a:buChar char="•"/>
+            </a:pPr>
+            <a:r>
+              <a:rPr lang="en-GB" sz="1600" dirty="0"/>
+              <a:t>Being sent to all research staff via new mailing list</a:t>
+            </a:r>
+          </a:p>
+          <a:p>
+            <a:pPr marL="800100" lvl="1" indent="-342900">
+              <a:buFont typeface="Arial" panose="020B0604020202020204" pitchFamily="34" charset="0"/>
+              <a:buChar char="•"/>
+            </a:pPr>
+            <a:r>
+              <a:rPr lang="en-GB" sz="1600" dirty="0"/>
+              <a:t>PGR Leads being asked to send out to PGRs</a:t>
+            </a:r>
+          </a:p>
+          <a:p>
+            <a:pPr marL="342900" indent="-342900">
+              <a:buFont typeface="Arial" panose="020B0604020202020204" pitchFamily="34" charset="0"/>
+              <a:buChar char="•"/>
+            </a:pPr>
+            <a:r>
+              <a:rPr lang="en-GB" sz="2000" dirty="0"/>
+              <a:t>Your opportunity to shape the future of research computing at </a:t>
+            </a:r>
+            <a:r>
+              <a:rPr lang="en-GB" sz="2000" dirty="0" err="1"/>
+              <a:t>UoB</a:t>
+            </a:r>
+            <a:r>
+              <a:rPr lang="en-GB" sz="2000" dirty="0"/>
+              <a:t>!</a:t>
+            </a:r>
+          </a:p>
+          <a:p>
+            <a:pPr marL="800100" lvl="1" indent="-342900">
+              <a:buFont typeface="Arial" panose="020B0604020202020204" pitchFamily="34" charset="0"/>
+              <a:buChar char="•"/>
+            </a:pPr>
+            <a:r>
+              <a:rPr lang="en-GB" sz="1600" dirty="0">
+                <a:hlinkClick r:id="rId2"/>
+              </a:rPr>
+              <a:t>Received 5 years of funding for extra training based on 2024 results</a:t>
+            </a:r>
+            <a:endParaRPr lang="en-GB" sz="1600" dirty="0"/>
+          </a:p>
+          <a:p>
+            <a:pPr marL="342900" indent="-342900">
+              <a:buFont typeface="Arial" panose="020B0604020202020204" pitchFamily="34" charset="0"/>
+              <a:buChar char="•"/>
+            </a:pPr>
+            <a:r>
+              <a:rPr lang="en-GB" sz="2000" dirty="0"/>
+              <a:t>Survey link</a:t>
+            </a:r>
+          </a:p>
+          <a:p>
+            <a:pPr marL="800100" lvl="1" indent="-342900">
+              <a:buFont typeface="Arial" panose="020B0604020202020204" pitchFamily="34" charset="0"/>
+              <a:buChar char="•"/>
+            </a:pPr>
+            <a:r>
+              <a:rPr lang="en-GB" sz="1600" dirty="0">
+                <a:hlinkClick r:id="rId3"/>
+              </a:rPr>
+              <a:t>https://app.onlinesurveys.jisc.ac.uk/s/bham/2026-it-needs-of-active-research</a:t>
+            </a:r>
+            <a:r>
+              <a:rPr lang="en-GB" sz="1600" dirty="0"/>
+              <a:t> </a:t>
+            </a:r>
+          </a:p>
+          <a:p>
+            <a:pPr marL="342900" indent="-342900">
+              <a:buFont typeface="Arial" panose="020B0604020202020204" pitchFamily="34" charset="0"/>
+              <a:buChar char="•"/>
+            </a:pPr>
+            <a:endParaRPr lang="en-GB" dirty="0"/>
+          </a:p>
+        </p:txBody>
+      </p:sp>
+      <p:pic>
+        <p:nvPicPr>
+          <p:cNvPr id="5" name="Picture 4" descr="A qr code on a white background&#10;&#10;AI-generated content may be incorrect.">
+            <a:extLst>
+              <a:ext uri="{FF2B5EF4-FFF2-40B4-BE49-F238E27FC236}">
+                <a16:creationId xmlns:a16="http://schemas.microsoft.com/office/drawing/2014/main" id="{6DBA7F14-E730-26A9-97F8-8BB8A20B684D}"/>
+              </a:ext>
+            </a:extLst>
+          </p:cNvPr>
+          <p:cNvPicPr>
+            <a:picLocks noChangeAspect="1"/>
+          </p:cNvPicPr>
+          <p:nvPr/>
+        </p:nvPicPr>
+        <p:blipFill>
+          <a:blip r:embed="rId4"/>
+          <a:stretch>
+            <a:fillRect/>
+          </a:stretch>
+        </p:blipFill>
+        <p:spPr>
+          <a:xfrm>
+            <a:off x="8146366" y="1080871"/>
+            <a:ext cx="3706836" cy="3706836"/>
+          </a:xfrm>
+          <a:prstGeom prst="rect">
+            <a:avLst/>
+          </a:prstGeom>
+        </p:spPr>
+      </p:pic>
+      <p:pic>
+        <p:nvPicPr>
+          <p:cNvPr id="6" name="Picture 5" descr="A white background with black text&#10;&#10;AI-generated content may be incorrect.">
+            <a:extLst>
+              <a:ext uri="{FF2B5EF4-FFF2-40B4-BE49-F238E27FC236}">
+                <a16:creationId xmlns:a16="http://schemas.microsoft.com/office/drawing/2014/main" id="{0F15C397-8423-6956-2F43-5D393BE0AE99}"/>
+              </a:ext>
+            </a:extLst>
+          </p:cNvPr>
+          <p:cNvPicPr>
+            <a:picLocks noChangeAspect="1"/>
+          </p:cNvPicPr>
+          <p:nvPr/>
+        </p:nvPicPr>
+        <p:blipFill>
+          <a:blip r:embed="rId5"/>
+          <a:stretch>
+            <a:fillRect/>
+          </a:stretch>
+        </p:blipFill>
+        <p:spPr>
+          <a:xfrm>
+            <a:off x="8146366" y="4753708"/>
+            <a:ext cx="3706836" cy="2085095"/>
+          </a:xfrm>
+          <a:prstGeom prst="rect">
+            <a:avLst/>
+          </a:prstGeom>
+        </p:spPr>
+      </p:pic>
+    </p:spTree>
+    <p:extLst>
+      <p:ext uri="{BB962C8B-B14F-4D97-AF65-F5344CB8AC3E}">
+        <p14:creationId xmlns:p14="http://schemas.microsoft.com/office/powerpoint/2010/main" val="25058625"/>
+      </p:ext>
+    </p:extLst>
+  </p:cSld>
+  <p:clrMapOvr>
+    <a:masterClrMapping/>
+  </p:clrMapOvr>
+</p:sld>
+</file>
+
 <file path=ppt/slides/slide2.xml><?xml version="1.0" encoding="utf-8"?>
 <p:sld xmlns:a="http://schemas.openxmlformats.org/drawingml/2006/main" xmlns:r="http://schemas.openxmlformats.org/officeDocument/2006/relationships" xmlns:p="http://schemas.openxmlformats.org/presentationml/2006/main">
   <p:cSld>
@@ -9991,7 +10233,7 @@
           <p:cNvPr id="2" name="Title 1">
             <a:extLst>
               <a:ext uri="{FF2B5EF4-FFF2-40B4-BE49-F238E27FC236}">
-                <a16:creationId xmlns:a16="http://schemas.microsoft.com/office/drawing/2014/main" id="{F7357C48-2C50-5587-5B64-24F7CE236783}"/>
+                <a16:creationId xmlns:a16="http://schemas.microsoft.com/office/drawing/2014/main" id="{2284C20E-5D3E-3218-03B3-EEE661375FA0}"/>
               </a:ext>
             </a:extLst>
           </p:cNvPr>
@@ -10009,7 +10251,7 @@
           <a:p>
             <a:r>
               <a:rPr lang="en-GB" dirty="0"/>
-              <a:t>2026 IT Needs of Active Research Survey</a:t>
+              <a:t>Please take a couple of minutes to fill in the course feedback form</a:t>
             </a:r>
           </a:p>
         </p:txBody>
@@ -10019,130 +10261,43 @@
           <p:cNvPr id="3" name="Content Placeholder 2">
             <a:extLst>
               <a:ext uri="{FF2B5EF4-FFF2-40B4-BE49-F238E27FC236}">
-                <a16:creationId xmlns:a16="http://schemas.microsoft.com/office/drawing/2014/main" id="{AE939116-DBB8-4101-FC45-CEDC7FD29B29}"/>
-              </a:ext>
-            </a:extLst>
-          </p:cNvPr>
-          <p:cNvSpPr>
-            <a:spLocks noGrp="1"/>
-          </p:cNvSpPr>
-          <p:nvPr>
-            <p:ph sz="half" idx="1"/>
-          </p:nvPr>
-        </p:nvSpPr>
-        <p:spPr>
-          <a:xfrm>
-            <a:off x="502921" y="1310641"/>
-            <a:ext cx="7175693" cy="4378960"/>
-          </a:xfrm>
-        </p:spPr>
-        <p:txBody>
-          <a:bodyPr>
-            <a:normAutofit/>
-          </a:bodyPr>
+                <a16:creationId xmlns:a16="http://schemas.microsoft.com/office/drawing/2014/main" id="{2B1B1492-02EC-0E19-74E0-6CD273B98FC5}"/>
+              </a:ext>
+            </a:extLst>
+          </p:cNvPr>
+          <p:cNvSpPr>
+            <a:spLocks noGrp="1"/>
+          </p:cNvSpPr>
+          <p:nvPr>
+            <p:ph idx="1"/>
+          </p:nvPr>
+        </p:nvSpPr>
+        <p:spPr>
+          <a:xfrm>
+            <a:off x="838200" y="2981261"/>
+            <a:ext cx="5937504" cy="1603375"/>
+          </a:xfrm>
+        </p:spPr>
+        <p:txBody>
+          <a:bodyPr/>
           <a:lstStyle/>
           <a:p>
-            <a:pPr marL="342900" indent="-342900">
-              <a:buFont typeface="Arial" panose="020B0604020202020204" pitchFamily="34" charset="0"/>
-              <a:buChar char="•"/>
-            </a:pPr>
-            <a:r>
-              <a:rPr lang="en-GB" sz="2200" dirty="0"/>
-              <a:t>Survey going live Monday 23 February for 4 weeks </a:t>
-            </a:r>
-          </a:p>
-          <a:p>
-            <a:pPr marL="800100" lvl="1" indent="-342900">
-              <a:buFont typeface="Arial" panose="020B0604020202020204" pitchFamily="34" charset="0"/>
-              <a:buChar char="•"/>
-            </a:pPr>
-            <a:r>
-              <a:rPr lang="en-GB" sz="1600" dirty="0"/>
-              <a:t>Being sent to all research staff via new mailing list</a:t>
-            </a:r>
-          </a:p>
-          <a:p>
-            <a:pPr marL="800100" lvl="1" indent="-342900">
-              <a:buFont typeface="Arial" panose="020B0604020202020204" pitchFamily="34" charset="0"/>
-              <a:buChar char="•"/>
-            </a:pPr>
-            <a:r>
-              <a:rPr lang="en-GB" sz="1600" dirty="0"/>
-              <a:t>PGR Leads being asked to send out to PGRs</a:t>
-            </a:r>
-          </a:p>
-          <a:p>
-            <a:pPr marL="342900" indent="-342900">
-              <a:buFont typeface="Arial" panose="020B0604020202020204" pitchFamily="34" charset="0"/>
-              <a:buChar char="•"/>
-            </a:pPr>
-            <a:r>
-              <a:rPr lang="en-GB" sz="2000" dirty="0"/>
-              <a:t>Your opportunity to shape the future of research computing at </a:t>
-            </a:r>
-            <a:r>
-              <a:rPr lang="en-GB" sz="2000" dirty="0" err="1"/>
-              <a:t>UoB</a:t>
-            </a:r>
-            <a:r>
-              <a:rPr lang="en-GB" sz="2000" dirty="0"/>
-              <a:t>!</a:t>
-            </a:r>
-          </a:p>
-          <a:p>
-            <a:pPr marL="800100" lvl="1" indent="-342900">
-              <a:buFont typeface="Arial" panose="020B0604020202020204" pitchFamily="34" charset="0"/>
-              <a:buChar char="•"/>
-            </a:pPr>
-            <a:r>
-              <a:rPr lang="en-GB" sz="1600" dirty="0">
+            <a:r>
+              <a:rPr lang="en-GB" dirty="0">
                 <a:hlinkClick r:id="rId2"/>
               </a:rPr>
-              <a:t>Received 5 years of funding for extra training based on 2024 results</a:t>
-            </a:r>
-            <a:endParaRPr lang="en-GB" sz="1600" dirty="0"/>
-          </a:p>
-          <a:p>
-            <a:pPr marL="342900" indent="-342900">
-              <a:buFont typeface="Arial" panose="020B0604020202020204" pitchFamily="34" charset="0"/>
-              <a:buChar char="•"/>
-            </a:pPr>
-            <a:r>
-              <a:rPr lang="en-GB" sz="2000" dirty="0"/>
-              <a:t>Survey link</a:t>
-            </a:r>
-          </a:p>
-          <a:p>
-            <a:pPr marL="800100" lvl="1" indent="-342900">
-              <a:buFont typeface="Arial" panose="020B0604020202020204" pitchFamily="34" charset="0"/>
-              <a:buChar char="•"/>
-            </a:pPr>
-            <a:r>
-              <a:rPr lang="en-GB" sz="1600" dirty="0">
-                <a:hlinkClick r:id="rId3"/>
-              </a:rPr>
-              <a:t>https://app.onlinesurveys.jisc.ac.uk/s/bham/2026-it-needs-of-active-research</a:t>
-            </a:r>
-            <a:r>
-              <a:rPr lang="en-GB" sz="1600" dirty="0"/>
-              <a:t> </a:t>
-            </a:r>
-          </a:p>
-          <a:p>
-            <a:pPr marL="342900" indent="-342900">
-              <a:buFont typeface="Arial" panose="020B0604020202020204" pitchFamily="34" charset="0"/>
-              <a:buChar char="•"/>
-            </a:pPr>
+              <a:t>Introduction to Web Scraping - 10 Mar 2026 - BEAR Training Feedback form – Fill out form</a:t>
+            </a:r>
             <a:endParaRPr lang="en-GB" dirty="0"/>
           </a:p>
         </p:txBody>
       </p:sp>
       <p:pic>
         <p:nvPicPr>
-          <p:cNvPr id="5" name="Picture 4" descr="A qr code on a white background&#10;&#10;AI-generated content may be incorrect.">
-            <a:extLst>
-              <a:ext uri="{FF2B5EF4-FFF2-40B4-BE49-F238E27FC236}">
-                <a16:creationId xmlns:a16="http://schemas.microsoft.com/office/drawing/2014/main" id="{6DBA7F14-E730-26A9-97F8-8BB8A20B684D}"/>
+          <p:cNvPr id="5" name="Picture 4">
+            <a:extLst>
+              <a:ext uri="{FF2B5EF4-FFF2-40B4-BE49-F238E27FC236}">
+                <a16:creationId xmlns:a16="http://schemas.microsoft.com/office/drawing/2014/main" id="{1E7E3F11-1AFD-82E7-761D-C54D0770D498}"/>
               </a:ext>
             </a:extLst>
           </p:cNvPr>
@@ -10152,45 +10307,15 @@
           <p:nvPr/>
         </p:nvPicPr>
         <p:blipFill>
-          <a:blip r:embed="rId4"/>
+          <a:blip r:embed="rId3"/>
           <a:stretch>
             <a:fillRect/>
           </a:stretch>
         </p:blipFill>
         <p:spPr>
           <a:xfrm>
-            <a:off x="8146366" y="1080871"/>
-            <a:ext cx="3706836" cy="3706836"/>
-          </a:xfrm>
-          <a:prstGeom prst="rect">
-            <a:avLst/>
-          </a:prstGeom>
-        </p:spPr>
-      </p:pic>
-      <p:pic>
-        <p:nvPicPr>
-          <p:cNvPr id="6" name="Picture 5" descr="A white background with black text&#10;&#10;AI-generated content may be incorrect.">
-            <a:extLst>
-              <a:ext uri="{FF2B5EF4-FFF2-40B4-BE49-F238E27FC236}">
-                <a16:creationId xmlns:a16="http://schemas.microsoft.com/office/drawing/2014/main" id="{0F15C397-8423-6956-2F43-5D393BE0AE99}"/>
-              </a:ext>
-            </a:extLst>
-          </p:cNvPr>
-          <p:cNvPicPr>
-            <a:picLocks noChangeAspect="1"/>
-          </p:cNvPicPr>
-          <p:nvPr/>
-        </p:nvPicPr>
-        <p:blipFill>
-          <a:blip r:embed="rId5"/>
-          <a:stretch>
-            <a:fillRect/>
-          </a:stretch>
-        </p:blipFill>
-        <p:spPr>
-          <a:xfrm>
-            <a:off x="8146366" y="4753708"/>
-            <a:ext cx="3706836" cy="2085095"/>
+            <a:off x="7362825" y="2105025"/>
+            <a:ext cx="3355848" cy="3355848"/>
           </a:xfrm>
           <a:prstGeom prst="rect">
             <a:avLst/>
@@ -10200,7 +10325,7 @@
     </p:spTree>
     <p:extLst>
       <p:ext uri="{BB962C8B-B14F-4D97-AF65-F5344CB8AC3E}">
-        <p14:creationId xmlns:p14="http://schemas.microsoft.com/office/powerpoint/2010/main" val="25058625"/>
+        <p14:creationId xmlns:p14="http://schemas.microsoft.com/office/powerpoint/2010/main" val="3623720434"/>
       </p:ext>
     </p:extLst>
   </p:cSld>

</xml_diff>